<commit_message>
Update Unreal Engine pptx
</commit_message>
<xml_diff>
--- a/Presentation/Unrealengine pp.pptx
+++ b/Presentation/Unrealengine pp.pptx
@@ -7,14 +7,16 @@
   <p:sldIdLst>
     <p:sldId id="256" r:id="rId5"/>
     <p:sldId id="263" r:id="rId6"/>
-    <p:sldId id="258" r:id="rId7"/>
+    <p:sldId id="271" r:id="rId7"/>
     <p:sldId id="257" r:id="rId8"/>
-    <p:sldId id="264" r:id="rId9"/>
-    <p:sldId id="265" r:id="rId10"/>
-    <p:sldId id="266" r:id="rId11"/>
-    <p:sldId id="267" r:id="rId12"/>
-    <p:sldId id="268" r:id="rId13"/>
-    <p:sldId id="269" r:id="rId14"/>
+    <p:sldId id="270" r:id="rId9"/>
+    <p:sldId id="264" r:id="rId10"/>
+    <p:sldId id="272" r:id="rId11"/>
+    <p:sldId id="265" r:id="rId12"/>
+    <p:sldId id="266" r:id="rId13"/>
+    <p:sldId id="267" r:id="rId14"/>
+    <p:sldId id="268" r:id="rId15"/>
+    <p:sldId id="269" r:id="rId16"/>
   </p:sldIdLst>
   <p:sldSz cx="12192000" cy="6858000"/>
   <p:notesSz cx="6858000" cy="9144000"/>
@@ -772,7 +774,7 @@
           <a:p>
             <a:fld id="{CE70ADAD-9187-47F9-A249-492AE8E7021B}" type="datetimeFigureOut">
               <a:rPr lang="de-CH" smtClean="0"/>
-              <a:t>11.02.2026</a:t>
+              <a:t>04.03.2026</a:t>
             </a:fld>
             <a:endParaRPr lang="de-CH"/>
           </a:p>
@@ -972,7 +974,7 @@
           <a:p>
             <a:fld id="{CE70ADAD-9187-47F9-A249-492AE8E7021B}" type="datetimeFigureOut">
               <a:rPr lang="de-CH" smtClean="0"/>
-              <a:t>11.02.2026</a:t>
+              <a:t>04.03.2026</a:t>
             </a:fld>
             <a:endParaRPr lang="de-CH"/>
           </a:p>
@@ -1182,7 +1184,7 @@
           <a:p>
             <a:fld id="{CE70ADAD-9187-47F9-A249-492AE8E7021B}" type="datetimeFigureOut">
               <a:rPr lang="de-CH" smtClean="0"/>
-              <a:t>11.02.2026</a:t>
+              <a:t>04.03.2026</a:t>
             </a:fld>
             <a:endParaRPr lang="de-CH"/>
           </a:p>
@@ -1382,7 +1384,7 @@
           <a:p>
             <a:fld id="{CE70ADAD-9187-47F9-A249-492AE8E7021B}" type="datetimeFigureOut">
               <a:rPr lang="de-CH" smtClean="0"/>
-              <a:t>11.02.2026</a:t>
+              <a:t>04.03.2026</a:t>
             </a:fld>
             <a:endParaRPr lang="de-CH"/>
           </a:p>
@@ -1658,7 +1660,7 @@
           <a:p>
             <a:fld id="{CE70ADAD-9187-47F9-A249-492AE8E7021B}" type="datetimeFigureOut">
               <a:rPr lang="de-CH" smtClean="0"/>
-              <a:t>11.02.2026</a:t>
+              <a:t>04.03.2026</a:t>
             </a:fld>
             <a:endParaRPr lang="de-CH"/>
           </a:p>
@@ -1926,7 +1928,7 @@
           <a:p>
             <a:fld id="{CE70ADAD-9187-47F9-A249-492AE8E7021B}" type="datetimeFigureOut">
               <a:rPr lang="de-CH" smtClean="0"/>
-              <a:t>11.02.2026</a:t>
+              <a:t>04.03.2026</a:t>
             </a:fld>
             <a:endParaRPr lang="de-CH"/>
           </a:p>
@@ -2341,7 +2343,7 @@
           <a:p>
             <a:fld id="{CE70ADAD-9187-47F9-A249-492AE8E7021B}" type="datetimeFigureOut">
               <a:rPr lang="de-CH" smtClean="0"/>
-              <a:t>11.02.2026</a:t>
+              <a:t>04.03.2026</a:t>
             </a:fld>
             <a:endParaRPr lang="de-CH"/>
           </a:p>
@@ -2483,7 +2485,7 @@
           <a:p>
             <a:fld id="{CE70ADAD-9187-47F9-A249-492AE8E7021B}" type="datetimeFigureOut">
               <a:rPr lang="de-CH" smtClean="0"/>
-              <a:t>11.02.2026</a:t>
+              <a:t>04.03.2026</a:t>
             </a:fld>
             <a:endParaRPr lang="de-CH"/>
           </a:p>
@@ -2596,7 +2598,7 @@
           <a:p>
             <a:fld id="{CE70ADAD-9187-47F9-A249-492AE8E7021B}" type="datetimeFigureOut">
               <a:rPr lang="de-CH" smtClean="0"/>
-              <a:t>11.02.2026</a:t>
+              <a:t>04.03.2026</a:t>
             </a:fld>
             <a:endParaRPr lang="de-CH"/>
           </a:p>
@@ -2909,7 +2911,7 @@
           <a:p>
             <a:fld id="{CE70ADAD-9187-47F9-A249-492AE8E7021B}" type="datetimeFigureOut">
               <a:rPr lang="de-CH" smtClean="0"/>
-              <a:t>11.02.2026</a:t>
+              <a:t>04.03.2026</a:t>
             </a:fld>
             <a:endParaRPr lang="de-CH"/>
           </a:p>
@@ -3198,7 +3200,7 @@
           <a:p>
             <a:fld id="{CE70ADAD-9187-47F9-A249-492AE8E7021B}" type="datetimeFigureOut">
               <a:rPr lang="de-CH" smtClean="0"/>
-              <a:t>11.02.2026</a:t>
+              <a:t>04.03.2026</a:t>
             </a:fld>
             <a:endParaRPr lang="de-CH"/>
           </a:p>
@@ -3441,7 +3443,7 @@
           <a:p>
             <a:fld id="{CE70ADAD-9187-47F9-A249-492AE8E7021B}" type="datetimeFigureOut">
               <a:rPr lang="de-CH" smtClean="0"/>
-              <a:t>11.02.2026</a:t>
+              <a:t>04.03.2026</a:t>
             </a:fld>
             <a:endParaRPr lang="de-CH"/>
           </a:p>
@@ -3880,8 +3882,8 @@
           <a:lstStyle/>
           <a:p>
             <a:r>
-              <a:rPr lang="de-CH"/>
-              <a:t>VR Game(Name)</a:t>
+              <a:rPr lang="de-CH" dirty="0"/>
+              <a:t>VR-Game(Name)</a:t>
             </a:r>
           </a:p>
         </p:txBody>
@@ -3908,22 +3910,17 @@
           <a:lstStyle/>
           <a:p>
             <a:r>
-              <a:rPr lang="de-CH"/>
+              <a:rPr lang="de-CH" dirty="0"/>
               <a:t>Elia, Tadej, Ben, </a:t>
             </a:r>
             <a:r>
-              <a:rPr lang="de-CH" err="1"/>
+              <a:rPr lang="de-CH" dirty="0" err="1"/>
               <a:t>Aurelien</a:t>
             </a:r>
             <a:r>
-              <a:rPr lang="de-CH"/>
-              <a:t>, </a:t>
-            </a:r>
-            <a:r>
-              <a:rPr lang="de-CH" err="1"/>
-              <a:t>Safal</a:t>
-            </a:r>
-            <a:endParaRPr lang="de-CH"/>
+              <a:rPr lang="de-CH" dirty="0"/>
+              <a:t>, Safal</a:t>
+            </a:r>
           </a:p>
         </p:txBody>
       </p:sp>
@@ -3962,6 +3959,193 @@
           <p:cNvPr id="2" name="Title 1">
             <a:extLst>
               <a:ext uri="{FF2B5EF4-FFF2-40B4-BE49-F238E27FC236}">
+                <a16:creationId xmlns:a16="http://schemas.microsoft.com/office/drawing/2014/main" id="{112B59C9-D7A8-0317-1968-38B52CCB7530}"/>
+              </a:ext>
+            </a:extLst>
+          </p:cNvPr>
+          <p:cNvSpPr>
+            <a:spLocks noGrp="1"/>
+          </p:cNvSpPr>
+          <p:nvPr>
+            <p:ph type="title"/>
+          </p:nvPr>
+        </p:nvSpPr>
+        <p:spPr/>
+        <p:txBody>
+          <a:bodyPr/>
+          <a:lstStyle/>
+          <a:p>
+            <a:r>
+              <a:rPr lang="en-US"/>
+              <a:t>Was hat </a:t>
+            </a:r>
+            <a:r>
+              <a:rPr lang="en-US" err="1"/>
+              <a:t>uns</a:t>
+            </a:r>
+            <a:r>
+              <a:rPr lang="en-US"/>
+              <a:t> überrascht?</a:t>
+            </a:r>
+          </a:p>
+        </p:txBody>
+      </p:sp>
+      <p:sp>
+        <p:nvSpPr>
+          <p:cNvPr id="3" name="Content Placeholder 2">
+            <a:extLst>
+              <a:ext uri="{FF2B5EF4-FFF2-40B4-BE49-F238E27FC236}">
+                <a16:creationId xmlns:a16="http://schemas.microsoft.com/office/drawing/2014/main" id="{2EDFF1AB-8964-7212-8FB4-CB8CDB97FAE3}"/>
+              </a:ext>
+            </a:extLst>
+          </p:cNvPr>
+          <p:cNvSpPr>
+            <a:spLocks noGrp="1"/>
+          </p:cNvSpPr>
+          <p:nvPr>
+            <p:ph idx="1"/>
+          </p:nvPr>
+        </p:nvSpPr>
+        <p:spPr/>
+        <p:txBody>
+          <a:bodyPr/>
+          <a:lstStyle/>
+          <a:p>
+            <a:r>
+              <a:rPr lang="en-US" dirty="0" err="1"/>
+              <a:t>Komplexität</a:t>
+            </a:r>
+            <a:r>
+              <a:rPr lang="en-US" dirty="0"/>
+              <a:t> von Software</a:t>
+            </a:r>
+          </a:p>
+          <a:p>
+            <a:endParaRPr lang="en-US" dirty="0"/>
+          </a:p>
+          <a:p>
+            <a:endParaRPr lang="en-US" dirty="0"/>
+          </a:p>
+        </p:txBody>
+      </p:sp>
+    </p:spTree>
+    <p:extLst>
+      <p:ext uri="{BB962C8B-B14F-4D97-AF65-F5344CB8AC3E}">
+        <p14:creationId xmlns:p14="http://schemas.microsoft.com/office/powerpoint/2010/main" val="761157137"/>
+      </p:ext>
+    </p:extLst>
+  </p:cSld>
+  <p:clrMapOvr>
+    <a:masterClrMapping/>
+  </p:clrMapOvr>
+</p:sld>
+</file>
+
+<file path=ppt/slides/slide11.xml><?xml version="1.0" encoding="utf-8"?>
+<p:sld xmlns:a="http://schemas.openxmlformats.org/drawingml/2006/main" xmlns:r="http://schemas.openxmlformats.org/officeDocument/2006/relationships" xmlns:p="http://schemas.openxmlformats.org/presentationml/2006/main">
+  <p:cSld>
+    <p:spTree>
+      <p:nvGrpSpPr>
+        <p:cNvPr id="1" name=""/>
+        <p:cNvGrpSpPr/>
+        <p:nvPr/>
+      </p:nvGrpSpPr>
+      <p:grpSpPr>
+        <a:xfrm>
+          <a:off x="0" y="0"/>
+          <a:ext cx="0" cy="0"/>
+          <a:chOff x="0" y="0"/>
+          <a:chExt cx="0" cy="0"/>
+        </a:xfrm>
+      </p:grpSpPr>
+      <p:sp>
+        <p:nvSpPr>
+          <p:cNvPr id="2" name="Title 1">
+            <a:extLst>
+              <a:ext uri="{FF2B5EF4-FFF2-40B4-BE49-F238E27FC236}">
+                <a16:creationId xmlns:a16="http://schemas.microsoft.com/office/drawing/2014/main" id="{AFF46E95-2E97-E61B-88B9-6E1A97F1EF1D}"/>
+              </a:ext>
+            </a:extLst>
+          </p:cNvPr>
+          <p:cNvSpPr>
+            <a:spLocks noGrp="1"/>
+          </p:cNvSpPr>
+          <p:nvPr>
+            <p:ph type="title"/>
+          </p:nvPr>
+        </p:nvSpPr>
+        <p:spPr/>
+        <p:txBody>
+          <a:bodyPr/>
+          <a:lstStyle/>
+          <a:p>
+            <a:r>
+              <a:rPr lang="en-US"/>
+              <a:t>Reflektion</a:t>
+            </a:r>
+          </a:p>
+        </p:txBody>
+      </p:sp>
+      <p:sp>
+        <p:nvSpPr>
+          <p:cNvPr id="3" name="Content Placeholder 2">
+            <a:extLst>
+              <a:ext uri="{FF2B5EF4-FFF2-40B4-BE49-F238E27FC236}">
+                <a16:creationId xmlns:a16="http://schemas.microsoft.com/office/drawing/2014/main" id="{617DA1C0-367D-6611-4054-E45F28C96540}"/>
+              </a:ext>
+            </a:extLst>
+          </p:cNvPr>
+          <p:cNvSpPr>
+            <a:spLocks noGrp="1"/>
+          </p:cNvSpPr>
+          <p:nvPr>
+            <p:ph idx="1"/>
+          </p:nvPr>
+        </p:nvSpPr>
+        <p:spPr/>
+        <p:txBody>
+          <a:bodyPr/>
+          <a:lstStyle/>
+          <a:p>
+            <a:endParaRPr lang="en-US"/>
+          </a:p>
+        </p:txBody>
+      </p:sp>
+    </p:spTree>
+    <p:extLst>
+      <p:ext uri="{BB962C8B-B14F-4D97-AF65-F5344CB8AC3E}">
+        <p14:creationId xmlns:p14="http://schemas.microsoft.com/office/powerpoint/2010/main" val="4211665210"/>
+      </p:ext>
+    </p:extLst>
+  </p:cSld>
+  <p:clrMapOvr>
+    <a:masterClrMapping/>
+  </p:clrMapOvr>
+</p:sld>
+</file>
+
+<file path=ppt/slides/slide12.xml><?xml version="1.0" encoding="utf-8"?>
+<p:sld xmlns:a="http://schemas.openxmlformats.org/drawingml/2006/main" xmlns:r="http://schemas.openxmlformats.org/officeDocument/2006/relationships" xmlns:p="http://schemas.openxmlformats.org/presentationml/2006/main">
+  <p:cSld>
+    <p:spTree>
+      <p:nvGrpSpPr>
+        <p:cNvPr id="1" name=""/>
+        <p:cNvGrpSpPr/>
+        <p:nvPr/>
+      </p:nvGrpSpPr>
+      <p:grpSpPr>
+        <a:xfrm>
+          <a:off x="0" y="0"/>
+          <a:ext cx="0" cy="0"/>
+          <a:chOff x="0" y="0"/>
+          <a:chExt cx="0" cy="0"/>
+        </a:xfrm>
+      </p:grpSpPr>
+      <p:sp>
+        <p:nvSpPr>
+          <p:cNvPr id="2" name="Title 1">
+            <a:extLst>
+              <a:ext uri="{FF2B5EF4-FFF2-40B4-BE49-F238E27FC236}">
                 <a16:creationId xmlns:a16="http://schemas.microsoft.com/office/drawing/2014/main" id="{1429A97F-47BB-2EB8-B91D-07FC48C2C457}"/>
               </a:ext>
             </a:extLst>
@@ -4157,10 +4341,10 @@
       </p:grpSpPr>
       <p:sp>
         <p:nvSpPr>
-          <p:cNvPr id="2" name="Titel 1">
-            <a:extLst>
-              <a:ext uri="{FF2B5EF4-FFF2-40B4-BE49-F238E27FC236}">
-                <a16:creationId xmlns:a16="http://schemas.microsoft.com/office/drawing/2014/main" id="{318F1F6D-40C5-1BD9-423A-1B72E93E2327}"/>
+          <p:cNvPr id="2" name="Title 1">
+            <a:extLst>
+              <a:ext uri="{FF2B5EF4-FFF2-40B4-BE49-F238E27FC236}">
+                <a16:creationId xmlns:a16="http://schemas.microsoft.com/office/drawing/2014/main" id="{55D94D8F-F6AF-EF62-987C-DC96360DD0CF}"/>
               </a:ext>
             </a:extLst>
           </p:cNvPr>
@@ -4178,17 +4362,18 @@
           <a:p>
             <a:r>
               <a:rPr lang="de-CH"/>
-              <a:t>Tools (Gebraucht, Ungebraucht)</a:t>
-            </a:r>
-          </a:p>
-        </p:txBody>
-      </p:sp>
-      <p:sp>
-        <p:nvSpPr>
-          <p:cNvPr id="3" name="Inhaltsplatzhalter 2">
-            <a:extLst>
-              <a:ext uri="{FF2B5EF4-FFF2-40B4-BE49-F238E27FC236}">
-                <a16:creationId xmlns:a16="http://schemas.microsoft.com/office/drawing/2014/main" id="{CED2D7B6-A038-20F8-8D13-6A3B6506ABBD}"/>
+              <a:t>Tool</a:t>
+            </a:r>
+            <a:endParaRPr lang="de-CH" dirty="0"/>
+          </a:p>
+        </p:txBody>
+      </p:sp>
+      <p:sp>
+        <p:nvSpPr>
+          <p:cNvPr id="3" name="Content Placeholder 2">
+            <a:extLst>
+              <a:ext uri="{FF2B5EF4-FFF2-40B4-BE49-F238E27FC236}">
+                <a16:creationId xmlns:a16="http://schemas.microsoft.com/office/drawing/2014/main" id="{27945FCD-689E-3852-2F6F-5480D4DC8B91}"/>
               </a:ext>
             </a:extLst>
           </p:cNvPr>
@@ -4199,337 +4384,48 @@
             <p:ph idx="1"/>
           </p:nvPr>
         </p:nvSpPr>
-        <p:spPr>
-          <a:xfrm>
-            <a:off x="838200" y="1825625"/>
-            <a:ext cx="4580965" cy="4351338"/>
-          </a:xfrm>
-        </p:spPr>
-        <p:txBody>
-          <a:bodyPr vert="horz" lIns="91440" tIns="45720" rIns="91440" bIns="45720" rtlCol="0" anchor="t">
-            <a:normAutofit/>
-          </a:bodyPr>
-          <a:lstStyle/>
-          <a:p>
-            <a:r>
-              <a:rPr lang="de-CH"/>
-              <a:t>Gebraucht:</a:t>
-            </a:r>
-          </a:p>
-          <a:p>
-            <a:pPr lvl="1">
-              <a:buAutoNum type="arabicPeriod"/>
-            </a:pPr>
+        <p:spPr/>
+        <p:txBody>
+          <a:bodyPr/>
+          <a:lstStyle/>
+          <a:p>
             <a:r>
               <a:rPr lang="de-CH"/>
               <a:t>Unreal Engine</a:t>
             </a:r>
           </a:p>
           <a:p>
-            <a:pPr lvl="1">
-              <a:buAutoNum type="arabicPeriod"/>
-            </a:pPr>
-            <a:r>
-              <a:rPr lang="de-CH" err="1"/>
+            <a:r>
+              <a:rPr lang="de-CH"/>
               <a:t>Github</a:t>
             </a:r>
+          </a:p>
+          <a:p>
+            <a:r>
+              <a:rPr lang="de-CH"/>
+              <a:t>Sketchla</a:t>
+            </a:r>
+          </a:p>
+          <a:p>
+            <a:r>
+              <a:rPr lang="de-CH"/>
+              <a:t>Meta Quest Link</a:t>
+            </a:r>
+          </a:p>
+          <a:p>
             <a:endParaRPr lang="de-CH"/>
           </a:p>
           <a:p>
-            <a:pPr lvl="1">
-              <a:buAutoNum type="arabicPeriod"/>
-            </a:pPr>
-            <a:r>
-              <a:rPr lang="de-CH" err="1"/>
-              <a:t>Sketchfab</a:t>
-            </a:r>
-            <a:endParaRPr lang="de-CH"/>
-          </a:p>
-          <a:p>
-            <a:pPr lvl="1">
-              <a:buAutoNum type="arabicPeriod"/>
-            </a:pPr>
-            <a:r>
-              <a:rPr lang="de-CH" err="1"/>
-              <a:t>Meta</a:t>
-            </a:r>
-            <a:r>
-              <a:rPr lang="de-CH"/>
-              <a:t> Quest Link</a:t>
-            </a:r>
-          </a:p>
-          <a:p>
-            <a:pPr lvl="1">
-              <a:buAutoNum type="arabicPeriod"/>
-            </a:pPr>
-            <a:endParaRPr lang="de-CH"/>
-          </a:p>
-          <a:p>
-            <a:pPr lvl="1">
-              <a:buAutoNum type="arabicPeriod"/>
-            </a:pPr>
-            <a:endParaRPr lang="de-CH"/>
-          </a:p>
-          <a:p>
-            <a:pPr marL="914400" lvl="1" indent="-457200">
-              <a:buAutoNum type="arabicPeriod"/>
-            </a:pPr>
-            <a:endParaRPr lang="de-CH"/>
-          </a:p>
-        </p:txBody>
-      </p:sp>
-      <p:sp>
-        <p:nvSpPr>
-          <p:cNvPr id="6" name="Inhaltsplatzhalter 2">
-            <a:extLst>
-              <a:ext uri="{FF2B5EF4-FFF2-40B4-BE49-F238E27FC236}">
-                <a16:creationId xmlns:a16="http://schemas.microsoft.com/office/drawing/2014/main" id="{9FB268C8-0FC4-4D48-DF3D-D03B5D380208}"/>
-              </a:ext>
-            </a:extLst>
-          </p:cNvPr>
-          <p:cNvSpPr txBox="1">
-            <a:spLocks/>
-          </p:cNvSpPr>
-          <p:nvPr/>
-        </p:nvSpPr>
-        <p:spPr>
-          <a:xfrm>
-            <a:off x="6091518" y="1718048"/>
-            <a:ext cx="4580965" cy="4351338"/>
-          </a:xfrm>
-          <a:prstGeom prst="rect">
-            <a:avLst/>
-          </a:prstGeom>
-        </p:spPr>
-        <p:txBody>
-          <a:bodyPr vert="horz" lIns="91440" tIns="45720" rIns="91440" bIns="45720" rtlCol="0" anchor="t">
-            <a:normAutofit/>
-          </a:bodyPr>
-          <a:lstStyle>
-            <a:lvl1pPr marL="228600" indent="-228600" algn="l" defTabSz="914400" rtl="0" eaLnBrk="1" latinLnBrk="0" hangingPunct="1">
-              <a:lnSpc>
-                <a:spcPct val="90000"/>
-              </a:lnSpc>
-              <a:spcBef>
-                <a:spcPts val="1000"/>
-              </a:spcBef>
-              <a:buFont typeface="Arial" panose="020B0604020202020204" pitchFamily="34" charset="0"/>
-              <a:buChar char="•"/>
-              <a:defRPr sz="2800" kern="1200">
-                <a:solidFill>
-                  <a:schemeClr val="tx1"/>
-                </a:solidFill>
-                <a:latin typeface="+mn-lt"/>
-                <a:ea typeface="+mn-ea"/>
-                <a:cs typeface="+mn-cs"/>
-              </a:defRPr>
-            </a:lvl1pPr>
-            <a:lvl2pPr marL="685800" indent="-228600" algn="l" defTabSz="914400" rtl="0" eaLnBrk="1" latinLnBrk="0" hangingPunct="1">
-              <a:lnSpc>
-                <a:spcPct val="90000"/>
-              </a:lnSpc>
-              <a:spcBef>
-                <a:spcPts val="500"/>
-              </a:spcBef>
-              <a:buFont typeface="Arial" panose="020B0604020202020204" pitchFamily="34" charset="0"/>
-              <a:buChar char="•"/>
-              <a:defRPr sz="2400" kern="1200">
-                <a:solidFill>
-                  <a:schemeClr val="tx1"/>
-                </a:solidFill>
-                <a:latin typeface="+mn-lt"/>
-                <a:ea typeface="+mn-ea"/>
-                <a:cs typeface="+mn-cs"/>
-              </a:defRPr>
-            </a:lvl2pPr>
-            <a:lvl3pPr marL="1143000" indent="-228600" algn="l" defTabSz="914400" rtl="0" eaLnBrk="1" latinLnBrk="0" hangingPunct="1">
-              <a:lnSpc>
-                <a:spcPct val="90000"/>
-              </a:lnSpc>
-              <a:spcBef>
-                <a:spcPts val="500"/>
-              </a:spcBef>
-              <a:buFont typeface="Arial" panose="020B0604020202020204" pitchFamily="34" charset="0"/>
-              <a:buChar char="•"/>
-              <a:defRPr sz="2000" kern="1200">
-                <a:solidFill>
-                  <a:schemeClr val="tx1"/>
-                </a:solidFill>
-                <a:latin typeface="+mn-lt"/>
-                <a:ea typeface="+mn-ea"/>
-                <a:cs typeface="+mn-cs"/>
-              </a:defRPr>
-            </a:lvl3pPr>
-            <a:lvl4pPr marL="1600200" indent="-228600" algn="l" defTabSz="914400" rtl="0" eaLnBrk="1" latinLnBrk="0" hangingPunct="1">
-              <a:lnSpc>
-                <a:spcPct val="90000"/>
-              </a:lnSpc>
-              <a:spcBef>
-                <a:spcPts val="500"/>
-              </a:spcBef>
-              <a:buFont typeface="Arial" panose="020B0604020202020204" pitchFamily="34" charset="0"/>
-              <a:buChar char="•"/>
-              <a:defRPr sz="1800" kern="1200">
-                <a:solidFill>
-                  <a:schemeClr val="tx1"/>
-                </a:solidFill>
-                <a:latin typeface="+mn-lt"/>
-                <a:ea typeface="+mn-ea"/>
-                <a:cs typeface="+mn-cs"/>
-              </a:defRPr>
-            </a:lvl4pPr>
-            <a:lvl5pPr marL="2057400" indent="-228600" algn="l" defTabSz="914400" rtl="0" eaLnBrk="1" latinLnBrk="0" hangingPunct="1">
-              <a:lnSpc>
-                <a:spcPct val="90000"/>
-              </a:lnSpc>
-              <a:spcBef>
-                <a:spcPts val="500"/>
-              </a:spcBef>
-              <a:buFont typeface="Arial" panose="020B0604020202020204" pitchFamily="34" charset="0"/>
-              <a:buChar char="•"/>
-              <a:defRPr sz="1800" kern="1200">
-                <a:solidFill>
-                  <a:schemeClr val="tx1"/>
-                </a:solidFill>
-                <a:latin typeface="+mn-lt"/>
-                <a:ea typeface="+mn-ea"/>
-                <a:cs typeface="+mn-cs"/>
-              </a:defRPr>
-            </a:lvl5pPr>
-            <a:lvl6pPr marL="2514600" indent="-228600" algn="l" defTabSz="914400" rtl="0" eaLnBrk="1" latinLnBrk="0" hangingPunct="1">
-              <a:lnSpc>
-                <a:spcPct val="90000"/>
-              </a:lnSpc>
-              <a:spcBef>
-                <a:spcPts val="500"/>
-              </a:spcBef>
-              <a:buFont typeface="Arial" panose="020B0604020202020204" pitchFamily="34" charset="0"/>
-              <a:buChar char="•"/>
-              <a:defRPr sz="1800" kern="1200">
-                <a:solidFill>
-                  <a:schemeClr val="tx1"/>
-                </a:solidFill>
-                <a:latin typeface="+mn-lt"/>
-                <a:ea typeface="+mn-ea"/>
-                <a:cs typeface="+mn-cs"/>
-              </a:defRPr>
-            </a:lvl6pPr>
-            <a:lvl7pPr marL="2971800" indent="-228600" algn="l" defTabSz="914400" rtl="0" eaLnBrk="1" latinLnBrk="0" hangingPunct="1">
-              <a:lnSpc>
-                <a:spcPct val="90000"/>
-              </a:lnSpc>
-              <a:spcBef>
-                <a:spcPts val="500"/>
-              </a:spcBef>
-              <a:buFont typeface="Arial" panose="020B0604020202020204" pitchFamily="34" charset="0"/>
-              <a:buChar char="•"/>
-              <a:defRPr sz="1800" kern="1200">
-                <a:solidFill>
-                  <a:schemeClr val="tx1"/>
-                </a:solidFill>
-                <a:latin typeface="+mn-lt"/>
-                <a:ea typeface="+mn-ea"/>
-                <a:cs typeface="+mn-cs"/>
-              </a:defRPr>
-            </a:lvl7pPr>
-            <a:lvl8pPr marL="3429000" indent="-228600" algn="l" defTabSz="914400" rtl="0" eaLnBrk="1" latinLnBrk="0" hangingPunct="1">
-              <a:lnSpc>
-                <a:spcPct val="90000"/>
-              </a:lnSpc>
-              <a:spcBef>
-                <a:spcPts val="500"/>
-              </a:spcBef>
-              <a:buFont typeface="Arial" panose="020B0604020202020204" pitchFamily="34" charset="0"/>
-              <a:buChar char="•"/>
-              <a:defRPr sz="1800" kern="1200">
-                <a:solidFill>
-                  <a:schemeClr val="tx1"/>
-                </a:solidFill>
-                <a:latin typeface="+mn-lt"/>
-                <a:ea typeface="+mn-ea"/>
-                <a:cs typeface="+mn-cs"/>
-              </a:defRPr>
-            </a:lvl8pPr>
-            <a:lvl9pPr marL="3886200" indent="-228600" algn="l" defTabSz="914400" rtl="0" eaLnBrk="1" latinLnBrk="0" hangingPunct="1">
-              <a:lnSpc>
-                <a:spcPct val="90000"/>
-              </a:lnSpc>
-              <a:spcBef>
-                <a:spcPts val="500"/>
-              </a:spcBef>
-              <a:buFont typeface="Arial" panose="020B0604020202020204" pitchFamily="34" charset="0"/>
-              <a:buChar char="•"/>
-              <a:defRPr sz="1800" kern="1200">
-                <a:solidFill>
-                  <a:schemeClr val="tx1"/>
-                </a:solidFill>
-                <a:latin typeface="+mn-lt"/>
-                <a:ea typeface="+mn-ea"/>
-                <a:cs typeface="+mn-cs"/>
-              </a:defRPr>
-            </a:lvl9pPr>
-          </a:lstStyle>
-          <a:p>
-            <a:r>
-              <a:rPr lang="de-CH"/>
-              <a:t>Ungebraucht:</a:t>
-            </a:r>
-          </a:p>
-          <a:p>
-            <a:pPr lvl="1">
-              <a:buAutoNum type="arabicPeriod"/>
-            </a:pPr>
-            <a:r>
-              <a:rPr lang="de-CH"/>
-              <a:t>Unity</a:t>
-            </a:r>
-          </a:p>
-          <a:p>
-            <a:pPr lvl="1">
-              <a:buAutoNum type="arabicPeriod"/>
-            </a:pPr>
-            <a:r>
-              <a:rPr lang="de-CH"/>
-              <a:t>Developer Hub (</a:t>
-            </a:r>
-            <a:r>
-              <a:rPr lang="de-CH" err="1"/>
-              <a:t>Meta</a:t>
-            </a:r>
-            <a:r>
-              <a:rPr lang="de-CH"/>
-              <a:t>)</a:t>
-            </a:r>
-          </a:p>
-          <a:p>
-            <a:pPr lvl="1">
-              <a:buFont typeface="Arial" panose="020B0604020202020204" pitchFamily="34" charset="0"/>
-              <a:buAutoNum type="arabicPeriod"/>
-            </a:pPr>
-            <a:endParaRPr lang="de-CH"/>
-          </a:p>
-          <a:p>
-            <a:pPr lvl="1">
-              <a:buFont typeface="Arial" panose="020B0604020202020204" pitchFamily="34" charset="0"/>
-              <a:buAutoNum type="arabicPeriod"/>
-            </a:pPr>
-            <a:endParaRPr lang="de-CH"/>
-          </a:p>
-          <a:p>
-            <a:pPr marL="914400" lvl="1" indent="-457200">
-              <a:buFont typeface="Arial" panose="020B0604020202020204" pitchFamily="34" charset="0"/>
-              <a:buAutoNum type="arabicPeriod"/>
-            </a:pPr>
-            <a:endParaRPr lang="de-CH"/>
+            <a:endParaRPr lang="de-CH" dirty="0"/>
           </a:p>
         </p:txBody>
       </p:sp>
       <p:pic>
         <p:nvPicPr>
-          <p:cNvPr id="7" name="Picture 6" descr="Unreal Engine 5.7 is now available - Unreal Engine">
-            <a:extLst>
-              <a:ext uri="{FF2B5EF4-FFF2-40B4-BE49-F238E27FC236}">
-                <a16:creationId xmlns:a16="http://schemas.microsoft.com/office/drawing/2014/main" id="{D68F789F-672A-A77D-FC51-F190FF9FD261}"/>
+          <p:cNvPr id="12" name="Picture 11" descr="Download free Meta Quest Developer Hub for macOS">
+            <a:extLst>
+              <a:ext uri="{FF2B5EF4-FFF2-40B4-BE49-F238E27FC236}">
+                <a16:creationId xmlns:a16="http://schemas.microsoft.com/office/drawing/2014/main" id="{3000DB78-6805-8E8E-9E58-65200798EF89}"/>
               </a:ext>
             </a:extLst>
           </p:cNvPr>
@@ -4540,15 +4436,15 @@
         </p:nvPicPr>
         <p:blipFill>
           <a:blip r:embed="rId2"/>
-          <a:srcRect l="18741" r="17282"/>
+          <a:srcRect t="41" r="-2" b="-2"/>
           <a:stretch>
             <a:fillRect/>
           </a:stretch>
         </p:blipFill>
         <p:spPr>
           <a:xfrm>
-            <a:off x="3506722" y="1719544"/>
-            <a:ext cx="1061049" cy="872939"/>
+            <a:off x="6518833" y="932787"/>
+            <a:ext cx="2481812" cy="2480799"/>
           </a:xfrm>
           <a:prstGeom prst="rect">
             <a:avLst/>
@@ -4557,10 +4453,10 @@
       </p:pic>
       <p:pic>
         <p:nvPicPr>
-          <p:cNvPr id="8" name="Picture 7" descr="GitHub – Wikipedia">
-            <a:extLst>
-              <a:ext uri="{FF2B5EF4-FFF2-40B4-BE49-F238E27FC236}">
-                <a16:creationId xmlns:a16="http://schemas.microsoft.com/office/drawing/2014/main" id="{55442423-804C-E40A-7D91-E1682D0E84A4}"/>
+          <p:cNvPr id="13" name="Picture 12" descr="GitHub – Wikipedia">
+            <a:extLst>
+              <a:ext uri="{FF2B5EF4-FFF2-40B4-BE49-F238E27FC236}">
+                <a16:creationId xmlns:a16="http://schemas.microsoft.com/office/drawing/2014/main" id="{0A9EFDB0-E03A-3F19-B0F5-AB41B642A33E}"/>
               </a:ext>
             </a:extLst>
           </p:cNvPr>
@@ -4571,14 +4467,15 @@
         </p:nvPicPr>
         <p:blipFill>
           <a:blip r:embed="rId3"/>
+          <a:srcRect l="651" r="-1" b="-1"/>
           <a:stretch>
             <a:fillRect/>
           </a:stretch>
         </p:blipFill>
         <p:spPr>
           <a:xfrm>
-            <a:off x="4719638" y="2151250"/>
-            <a:ext cx="690843" cy="699808"/>
+            <a:off x="9056394" y="919877"/>
+            <a:ext cx="2477468" cy="2493709"/>
           </a:xfrm>
           <a:prstGeom prst="rect">
             <a:avLst/>
@@ -4587,10 +4484,10 @@
       </p:pic>
       <p:pic>
         <p:nvPicPr>
-          <p:cNvPr id="9" name="Picture 8" descr="Sketchfab - The best 3D viewer on the web">
-            <a:extLst>
-              <a:ext uri="{FF2B5EF4-FFF2-40B4-BE49-F238E27FC236}">
-                <a16:creationId xmlns:a16="http://schemas.microsoft.com/office/drawing/2014/main" id="{4C2AF0A9-D44E-09DD-C353-5565B48A3A7F}"/>
+          <p:cNvPr id="14" name="Picture 13" descr="Sketchfab - The best 3D viewer on the web">
+            <a:extLst>
+              <a:ext uri="{FF2B5EF4-FFF2-40B4-BE49-F238E27FC236}">
+                <a16:creationId xmlns:a16="http://schemas.microsoft.com/office/drawing/2014/main" id="{1EB3D228-3F8F-3836-EC99-6BA10076E471}"/>
               </a:ext>
             </a:extLst>
           </p:cNvPr>
@@ -4601,14 +4498,15 @@
         </p:nvPicPr>
         <p:blipFill>
           <a:blip r:embed="rId4"/>
+          <a:srcRect t="41" r="-2" b="-2"/>
           <a:stretch>
             <a:fillRect/>
           </a:stretch>
         </p:blipFill>
         <p:spPr>
           <a:xfrm>
-            <a:off x="3706626" y="2778778"/>
-            <a:ext cx="654985" cy="654985"/>
+            <a:off x="6518833" y="3470432"/>
+            <a:ext cx="2481812" cy="2480799"/>
           </a:xfrm>
           <a:prstGeom prst="rect">
             <a:avLst/>
@@ -4617,10 +4515,10 @@
       </p:pic>
       <p:pic>
         <p:nvPicPr>
-          <p:cNvPr id="10" name="Picture 9" descr="Download free Meta Quest Developer Hub for macOS">
-            <a:extLst>
-              <a:ext uri="{FF2B5EF4-FFF2-40B4-BE49-F238E27FC236}">
-                <a16:creationId xmlns:a16="http://schemas.microsoft.com/office/drawing/2014/main" id="{838D10CE-40F1-8C01-FDE2-42595FFF49C0}"/>
+          <p:cNvPr id="18" name="Picture 17" descr="Unreal Engine 5.7 is now available - Unreal Engine">
+            <a:extLst>
+              <a:ext uri="{FF2B5EF4-FFF2-40B4-BE49-F238E27FC236}">
+                <a16:creationId xmlns:a16="http://schemas.microsoft.com/office/drawing/2014/main" id="{73DC1C2D-6C11-72D2-D27C-B29389F1B15D}"/>
               </a:ext>
             </a:extLst>
           </p:cNvPr>
@@ -4631,75 +4529,15 @@
         </p:nvPicPr>
         <p:blipFill>
           <a:blip r:embed="rId5"/>
+          <a:srcRect l="24609" r="23234" b="2"/>
           <a:stretch>
             <a:fillRect/>
           </a:stretch>
         </p:blipFill>
         <p:spPr>
           <a:xfrm>
-            <a:off x="4576203" y="3101508"/>
-            <a:ext cx="1076325" cy="1076325"/>
-          </a:xfrm>
-          <a:prstGeom prst="rect">
-            <a:avLst/>
-          </a:prstGeom>
-        </p:spPr>
-      </p:pic>
-      <p:pic>
-        <p:nvPicPr>
-          <p:cNvPr id="17" name="Picture 16" descr="Unity (Spiel-Engine) – Wikipedia">
-            <a:extLst>
-              <a:ext uri="{FF2B5EF4-FFF2-40B4-BE49-F238E27FC236}">
-                <a16:creationId xmlns:a16="http://schemas.microsoft.com/office/drawing/2014/main" id="{F2B624DA-FCDE-A429-B7CF-8077A665D396}"/>
-              </a:ext>
-            </a:extLst>
-          </p:cNvPr>
-          <p:cNvPicPr>
-            <a:picLocks noChangeAspect="1"/>
-          </p:cNvPicPr>
-          <p:nvPr/>
-        </p:nvPicPr>
-        <p:blipFill>
-          <a:blip r:embed="rId6"/>
-          <a:stretch>
-            <a:fillRect/>
-          </a:stretch>
-        </p:blipFill>
-        <p:spPr>
-          <a:xfrm>
-            <a:off x="9133354" y="1462368"/>
-            <a:ext cx="1885950" cy="723900"/>
-          </a:xfrm>
-          <a:prstGeom prst="rect">
-            <a:avLst/>
-          </a:prstGeom>
-        </p:spPr>
-      </p:pic>
-      <p:pic>
-        <p:nvPicPr>
-          <p:cNvPr id="4" name="Picture 3" descr="Oculus Developer Hub 2.0 | Meta Horizon OS Developers">
-            <a:extLst>
-              <a:ext uri="{FF2B5EF4-FFF2-40B4-BE49-F238E27FC236}">
-                <a16:creationId xmlns:a16="http://schemas.microsoft.com/office/drawing/2014/main" id="{04BB6119-5ECC-0138-AF03-DC7F663871CF}"/>
-              </a:ext>
-            </a:extLst>
-          </p:cNvPr>
-          <p:cNvPicPr>
-            <a:picLocks noChangeAspect="1"/>
-          </p:cNvPicPr>
-          <p:nvPr/>
-        </p:nvPicPr>
-        <p:blipFill>
-          <a:blip r:embed="rId7"/>
-          <a:srcRect l="20186" t="13842" r="21088" b="8993"/>
-          <a:stretch>
-            <a:fillRect/>
-          </a:stretch>
-        </p:blipFill>
-        <p:spPr>
-          <a:xfrm>
-            <a:off x="9911751" y="2778777"/>
-            <a:ext cx="1107553" cy="999593"/>
+            <a:off x="9056394" y="3463675"/>
+            <a:ext cx="2477468" cy="2493709"/>
           </a:xfrm>
           <a:prstGeom prst="rect">
             <a:avLst/>
@@ -4709,7 +4547,7 @@
     </p:spTree>
     <p:extLst>
       <p:ext uri="{BB962C8B-B14F-4D97-AF65-F5344CB8AC3E}">
-        <p14:creationId xmlns:p14="http://schemas.microsoft.com/office/powerpoint/2010/main" val="4025588667"/>
+        <p14:creationId xmlns:p14="http://schemas.microsoft.com/office/powerpoint/2010/main" val="3271530750"/>
       </p:ext>
     </p:extLst>
   </p:cSld>
@@ -4758,7 +4596,7 @@
           <a:lstStyle/>
           <a:p>
             <a:r>
-              <a:rPr lang="de-CH"/>
+              <a:rPr lang="de-CH" dirty="0"/>
               <a:t>Endresultat vs. Zielsetzung</a:t>
             </a:r>
           </a:p>
@@ -4787,15 +4625,75 @@
           </a:bodyPr>
           <a:lstStyle/>
           <a:p>
-            <a:r>
-              <a:rPr lang="de-CH"/>
+            <a:pPr marL="0" indent="0">
+              <a:buNone/>
+            </a:pPr>
+            <a:r>
+              <a:rPr lang="de-CH" dirty="0"/>
               <a:t>Wie hat sich das Projekt entwickelt?</a:t>
             </a:r>
           </a:p>
           <a:p>
-            <a:r>
-              <a:rPr lang="de-CH"/>
-              <a:t>Was wurde erreicht? Was nicht?</a:t>
+            <a:pPr lvl="1"/>
+            <a:r>
+              <a:rPr lang="de-CH" dirty="0"/>
+              <a:t>Erst war es schwierig (Unreal Engine)</a:t>
+            </a:r>
+          </a:p>
+          <a:p>
+            <a:pPr lvl="1"/>
+            <a:r>
+              <a:rPr lang="de-CH" dirty="0"/>
+              <a:t>Haben die Tutorials gesehen</a:t>
+            </a:r>
+          </a:p>
+          <a:p>
+            <a:pPr lvl="1"/>
+            <a:r>
+              <a:rPr lang="de-CH" dirty="0"/>
+              <a:t>Haben Assets von Sketchlab installiert:</a:t>
+            </a:r>
+          </a:p>
+          <a:p>
+            <a:pPr lvl="2"/>
+            <a:r>
+              <a:rPr lang="de-CH" dirty="0"/>
+              <a:t>Environment</a:t>
+            </a:r>
+          </a:p>
+          <a:p>
+            <a:pPr lvl="2"/>
+            <a:r>
+              <a:rPr lang="de-CH" dirty="0"/>
+              <a:t>Zombie</a:t>
+            </a:r>
+          </a:p>
+          <a:p>
+            <a:pPr lvl="2"/>
+            <a:r>
+              <a:rPr lang="de-CH" dirty="0"/>
+              <a:t>Waffe</a:t>
+            </a:r>
+          </a:p>
+          <a:p>
+            <a:pPr lvl="1"/>
+            <a:r>
+              <a:rPr lang="de-CH" dirty="0"/>
+              <a:t>Anwendung in Unreal</a:t>
+            </a:r>
+          </a:p>
+          <a:p>
+            <a:pPr lvl="1"/>
+            <a:r>
+              <a:rPr lang="de-CH" dirty="0"/>
+              <a:t>Lustige Moments</a:t>
+            </a:r>
+          </a:p>
+          <a:p>
+            <a:pPr lvl="1"/>
+            <a:r>
+              <a:rPr lang="de-CH" dirty="0"/>
+              <a:t>Am Ende das Produkt</a:t>
             </a:r>
           </a:p>
         </p:txBody>
@@ -4835,7 +4733,7 @@
           <p:cNvPr id="2" name="Title 1">
             <a:extLst>
               <a:ext uri="{FF2B5EF4-FFF2-40B4-BE49-F238E27FC236}">
-                <a16:creationId xmlns:a16="http://schemas.microsoft.com/office/drawing/2014/main" id="{3DB50063-4FF0-00D5-65F4-4D9CE7CEBEA7}"/>
+                <a16:creationId xmlns:a16="http://schemas.microsoft.com/office/drawing/2014/main" id="{6FA80357-5CE1-D7BF-974B-3F68E01B978F}"/>
               </a:ext>
             </a:extLst>
           </p:cNvPr>
@@ -4852,16 +4750,8 @@
           <a:lstStyle/>
           <a:p>
             <a:r>
-              <a:rPr lang="en-US"/>
-              <a:t>Was lief gut? / Wo gab es </a:t>
-            </a:r>
-            <a:r>
-              <a:rPr lang="en-US" err="1"/>
-              <a:t>Probleme</a:t>
-            </a:r>
-            <a:r>
-              <a:rPr lang="en-US"/>
-              <a:t>?</a:t>
+              <a:rPr lang="de-CH" dirty="0"/>
+              <a:t>Endresultat vs. Zielsetzung</a:t>
             </a:r>
           </a:p>
         </p:txBody>
@@ -4871,7 +4761,7 @@
           <p:cNvPr id="3" name="Content Placeholder 2">
             <a:extLst>
               <a:ext uri="{FF2B5EF4-FFF2-40B4-BE49-F238E27FC236}">
-                <a16:creationId xmlns:a16="http://schemas.microsoft.com/office/drawing/2014/main" id="{1C7C46DD-AC74-255F-912D-68F4AD95857D}"/>
+                <a16:creationId xmlns:a16="http://schemas.microsoft.com/office/drawing/2014/main" id="{586E4D9D-7817-5D55-78D1-D8F6CB4FC5E0}"/>
               </a:ext>
             </a:extLst>
           </p:cNvPr>
@@ -4887,14 +4777,20 @@
           <a:bodyPr/>
           <a:lstStyle/>
           <a:p>
-            <a:endParaRPr lang="en-US"/>
+            <a:pPr marL="0" indent="0">
+              <a:buNone/>
+            </a:pPr>
+            <a:r>
+              <a:rPr lang="de-CH" dirty="0"/>
+              <a:t>Was wurde erreicht? Was nicht?</a:t>
+            </a:r>
           </a:p>
         </p:txBody>
       </p:sp>
     </p:spTree>
     <p:extLst>
       <p:ext uri="{BB962C8B-B14F-4D97-AF65-F5344CB8AC3E}">
-        <p14:creationId xmlns:p14="http://schemas.microsoft.com/office/powerpoint/2010/main" val="2396213657"/>
+        <p14:creationId xmlns:p14="http://schemas.microsoft.com/office/powerpoint/2010/main" val="2764003610"/>
       </p:ext>
     </p:extLst>
   </p:cSld>
@@ -4926,7 +4822,7 @@
           <p:cNvPr id="2" name="Title 1">
             <a:extLst>
               <a:ext uri="{FF2B5EF4-FFF2-40B4-BE49-F238E27FC236}">
-                <a16:creationId xmlns:a16="http://schemas.microsoft.com/office/drawing/2014/main" id="{F561AD8C-36DD-7829-BD8E-DA31B4195134}"/>
+                <a16:creationId xmlns:a16="http://schemas.microsoft.com/office/drawing/2014/main" id="{3DB50063-4FF0-00D5-65F4-4D9CE7CEBEA7}"/>
               </a:ext>
             </a:extLst>
           </p:cNvPr>
@@ -4943,79 +4839,88 @@
           <a:lstStyle/>
           <a:p>
             <a:r>
-              <a:rPr lang="en-US" err="1"/>
-              <a:t>Worauf</a:t>
-            </a:r>
-            <a:r>
-              <a:rPr lang="en-US"/>
+              <a:rPr lang="en-US" dirty="0"/>
+              <a:t>Was lief gut?</a:t>
+            </a:r>
+          </a:p>
+        </p:txBody>
+      </p:sp>
+      <p:sp>
+        <p:nvSpPr>
+          <p:cNvPr id="3" name="Content Placeholder 2">
+            <a:extLst>
+              <a:ext uri="{FF2B5EF4-FFF2-40B4-BE49-F238E27FC236}">
+                <a16:creationId xmlns:a16="http://schemas.microsoft.com/office/drawing/2014/main" id="{1C7C46DD-AC74-255F-912D-68F4AD95857D}"/>
+              </a:ext>
+            </a:extLst>
+          </p:cNvPr>
+          <p:cNvSpPr>
+            <a:spLocks noGrp="1"/>
+          </p:cNvSpPr>
+          <p:nvPr>
+            <p:ph idx="1"/>
+          </p:nvPr>
+        </p:nvSpPr>
+        <p:spPr/>
+        <p:txBody>
+          <a:bodyPr/>
+          <a:lstStyle/>
+          <a:p>
+            <a:r>
+              <a:rPr lang="en-US" dirty="0"/>
+              <a:t>Waffen </a:t>
+            </a:r>
+            <a:r>
+              <a:rPr lang="en-US" dirty="0" err="1"/>
+              <a:t>schiessen</a:t>
+            </a:r>
+            <a:r>
+              <a:rPr lang="en-US" dirty="0"/>
+              <a:t> direct</a:t>
+            </a:r>
+          </a:p>
+          <a:p>
+            <a:r>
+              <a:rPr lang="en-US" dirty="0"/>
+              <a:t>Das </a:t>
+            </a:r>
+            <a:r>
+              <a:rPr lang="en-US" dirty="0" err="1"/>
+              <a:t>Skeket</a:t>
+            </a:r>
+            <a:r>
+              <a:rPr lang="en-US" dirty="0"/>
+              <a:t> des Zombies</a:t>
+            </a:r>
+          </a:p>
+          <a:p>
+            <a:r>
+              <a:rPr lang="en-US" dirty="0"/>
+              <a:t>Die Blueprints von Assets </a:t>
+            </a:r>
+            <a:r>
+              <a:rPr lang="en-US" dirty="0" err="1"/>
+              <a:t>funkioneren</a:t>
+            </a:r>
+            <a:r>
+              <a:rPr lang="en-US" dirty="0"/>
               <a:t> </a:t>
             </a:r>
             <a:r>
-              <a:rPr lang="en-US" err="1"/>
-              <a:t>sind</a:t>
-            </a:r>
-            <a:r>
-              <a:rPr lang="en-US"/>
-              <a:t> </a:t>
-            </a:r>
-            <a:r>
-              <a:rPr lang="en-US" err="1"/>
-              <a:t>wir</a:t>
-            </a:r>
-            <a:r>
-              <a:rPr lang="en-US"/>
-              <a:t> </a:t>
-            </a:r>
-            <a:r>
-              <a:rPr lang="de-CH"/>
-              <a:t>stolz</a:t>
-            </a:r>
-            <a:r>
-              <a:rPr lang="en-US"/>
-              <a:t> (</a:t>
-            </a:r>
-            <a:r>
-              <a:rPr lang="en-US" err="1"/>
-              <a:t>Lösungen</a:t>
-            </a:r>
-            <a:r>
-              <a:rPr lang="en-US"/>
-              <a:t>)?</a:t>
-            </a:r>
-          </a:p>
-        </p:txBody>
-      </p:sp>
-      <p:sp>
-        <p:nvSpPr>
-          <p:cNvPr id="3" name="Content Placeholder 2">
-            <a:extLst>
-              <a:ext uri="{FF2B5EF4-FFF2-40B4-BE49-F238E27FC236}">
-                <a16:creationId xmlns:a16="http://schemas.microsoft.com/office/drawing/2014/main" id="{5C0E5C13-2F42-8335-E515-AB0AED9C2F34}"/>
-              </a:ext>
-            </a:extLst>
-          </p:cNvPr>
-          <p:cNvSpPr>
-            <a:spLocks noGrp="1"/>
-          </p:cNvSpPr>
-          <p:nvPr>
-            <p:ph idx="1"/>
-          </p:nvPr>
-        </p:nvSpPr>
-        <p:spPr/>
-        <p:txBody>
-          <a:bodyPr vert="horz" lIns="91440" tIns="45720" rIns="91440" bIns="45720" rtlCol="0" anchor="t">
-            <a:normAutofit/>
-          </a:bodyPr>
-          <a:lstStyle/>
-          <a:p>
-            <a:endParaRPr lang="en-US" noProof="1"/>
+              <a:rPr lang="en-US" dirty="0" err="1"/>
+              <a:t>relativ</a:t>
+            </a:r>
+            <a:r>
+              <a:rPr lang="en-US" dirty="0"/>
+              <a:t> gut</a:t>
+            </a:r>
           </a:p>
         </p:txBody>
       </p:sp>
     </p:spTree>
     <p:extLst>
       <p:ext uri="{BB962C8B-B14F-4D97-AF65-F5344CB8AC3E}">
-        <p14:creationId xmlns:p14="http://schemas.microsoft.com/office/powerpoint/2010/main" val="297389937"/>
+        <p14:creationId xmlns:p14="http://schemas.microsoft.com/office/powerpoint/2010/main" val="2396213657"/>
       </p:ext>
     </p:extLst>
   </p:cSld>
@@ -5047,7 +4952,7 @@
           <p:cNvPr id="2" name="Title 1">
             <a:extLst>
               <a:ext uri="{FF2B5EF4-FFF2-40B4-BE49-F238E27FC236}">
-                <a16:creationId xmlns:a16="http://schemas.microsoft.com/office/drawing/2014/main" id="{1E28AFB1-8A7A-B172-D7B1-90A824228172}"/>
+                <a16:creationId xmlns:a16="http://schemas.microsoft.com/office/drawing/2014/main" id="{C509D8EE-FD03-E44D-78DF-BBC840618515}"/>
               </a:ext>
             </a:extLst>
           </p:cNvPr>
@@ -5064,25 +4969,18 @@
           <a:lstStyle/>
           <a:p>
             <a:r>
-              <a:rPr lang="en-US"/>
-              <a:t>Was </a:t>
-            </a:r>
-            <a:r>
-              <a:rPr lang="en-US" err="1"/>
-              <a:t>haben</a:t>
-            </a:r>
-            <a:r>
-              <a:rPr lang="en-US"/>
-              <a:t> </a:t>
-            </a:r>
-            <a:r>
-              <a:rPr lang="en-US" err="1"/>
-              <a:t>wir</a:t>
-            </a:r>
-            <a:r>
-              <a:rPr lang="en-US"/>
-              <a:t> gelernt?</a:t>
-            </a:r>
+              <a:rPr lang="en-US" dirty="0"/>
+              <a:t>Wo gab es </a:t>
+            </a:r>
+            <a:r>
+              <a:rPr lang="en-US" dirty="0" err="1"/>
+              <a:t>Probleme</a:t>
+            </a:r>
+            <a:r>
+              <a:rPr lang="en-US" dirty="0"/>
+              <a:t>?</a:t>
+            </a:r>
+            <a:endParaRPr lang="de-CH" dirty="0"/>
           </a:p>
         </p:txBody>
       </p:sp>
@@ -5091,7 +4989,7 @@
           <p:cNvPr id="3" name="Content Placeholder 2">
             <a:extLst>
               <a:ext uri="{FF2B5EF4-FFF2-40B4-BE49-F238E27FC236}">
-                <a16:creationId xmlns:a16="http://schemas.microsoft.com/office/drawing/2014/main" id="{A8AA9383-4EBA-9EBE-396A-538380AE735F}"/>
+                <a16:creationId xmlns:a16="http://schemas.microsoft.com/office/drawing/2014/main" id="{432D4058-0911-6FCC-922F-1388F0AC6705}"/>
               </a:ext>
             </a:extLst>
           </p:cNvPr>
@@ -5104,19 +5002,39 @@
         </p:nvSpPr>
         <p:spPr/>
         <p:txBody>
-          <a:bodyPr vert="horz" lIns="91440" tIns="45720" rIns="91440" bIns="45720" rtlCol="0" anchor="t">
-            <a:normAutofit/>
-          </a:bodyPr>
-          <a:lstStyle/>
-          <a:p>
-            <a:endParaRPr lang="en-US"/>
+          <a:bodyPr/>
+          <a:lstStyle/>
+          <a:p>
+            <a:r>
+              <a:rPr lang="en-US" dirty="0"/>
+              <a:t>Bullets </a:t>
+            </a:r>
+            <a:r>
+              <a:rPr lang="en-US" dirty="0" err="1"/>
+              <a:t>gehen</a:t>
+            </a:r>
+            <a:r>
+              <a:rPr lang="en-US" dirty="0"/>
+              <a:t> nicht </a:t>
+            </a:r>
+            <a:r>
+              <a:rPr lang="en-US" dirty="0" err="1"/>
+              <a:t>gerade</a:t>
+            </a:r>
+            <a:endParaRPr lang="en-US" dirty="0"/>
+          </a:p>
+          <a:p>
+            <a:r>
+              <a:rPr lang="en-US" dirty="0"/>
+              <a:t>Fucking Pivot</a:t>
+            </a:r>
           </a:p>
         </p:txBody>
       </p:sp>
     </p:spTree>
     <p:extLst>
       <p:ext uri="{BB962C8B-B14F-4D97-AF65-F5344CB8AC3E}">
-        <p14:creationId xmlns:p14="http://schemas.microsoft.com/office/powerpoint/2010/main" val="2624086703"/>
+        <p14:creationId xmlns:p14="http://schemas.microsoft.com/office/powerpoint/2010/main" val="3782719326"/>
       </p:ext>
     </p:extLst>
   </p:cSld>
@@ -5148,7 +5066,7 @@
           <p:cNvPr id="2" name="Title 1">
             <a:extLst>
               <a:ext uri="{FF2B5EF4-FFF2-40B4-BE49-F238E27FC236}">
-                <a16:creationId xmlns:a16="http://schemas.microsoft.com/office/drawing/2014/main" id="{112B59C9-D7A8-0317-1968-38B52CCB7530}"/>
+                <a16:creationId xmlns:a16="http://schemas.microsoft.com/office/drawing/2014/main" id="{F561AD8C-36DD-7829-BD8E-DA31B4195134}"/>
               </a:ext>
             </a:extLst>
           </p:cNvPr>
@@ -5165,16 +5083,44 @@
           <a:lstStyle/>
           <a:p>
             <a:r>
+              <a:rPr lang="en-US" err="1"/>
+              <a:t>Worauf</a:t>
+            </a:r>
+            <a:r>
               <a:rPr lang="en-US"/>
-              <a:t>Was hat </a:t>
+              <a:t> </a:t>
             </a:r>
             <a:r>
               <a:rPr lang="en-US" err="1"/>
-              <a:t>uns</a:t>
+              <a:t>sind</a:t>
             </a:r>
             <a:r>
               <a:rPr lang="en-US"/>
-              <a:t> überrascht?</a:t>
+              <a:t> </a:t>
+            </a:r>
+            <a:r>
+              <a:rPr lang="en-US" err="1"/>
+              <a:t>wir</a:t>
+            </a:r>
+            <a:r>
+              <a:rPr lang="en-US"/>
+              <a:t> </a:t>
+            </a:r>
+            <a:r>
+              <a:rPr lang="de-CH"/>
+              <a:t>stolz</a:t>
+            </a:r>
+            <a:r>
+              <a:rPr lang="en-US"/>
+              <a:t> (</a:t>
+            </a:r>
+            <a:r>
+              <a:rPr lang="en-US" err="1"/>
+              <a:t>Lösungen</a:t>
+            </a:r>
+            <a:r>
+              <a:rPr lang="en-US"/>
+              <a:t>)?</a:t>
             </a:r>
           </a:p>
         </p:txBody>
@@ -5184,7 +5130,7 @@
           <p:cNvPr id="3" name="Content Placeholder 2">
             <a:extLst>
               <a:ext uri="{FF2B5EF4-FFF2-40B4-BE49-F238E27FC236}">
-                <a16:creationId xmlns:a16="http://schemas.microsoft.com/office/drawing/2014/main" id="{2EDFF1AB-8964-7212-8FB4-CB8CDB97FAE3}"/>
+                <a16:creationId xmlns:a16="http://schemas.microsoft.com/office/drawing/2014/main" id="{5C0E5C13-2F42-8335-E515-AB0AED9C2F34}"/>
               </a:ext>
             </a:extLst>
           </p:cNvPr>
@@ -5197,17 +5143,31 @@
         </p:nvSpPr>
         <p:spPr/>
         <p:txBody>
-          <a:bodyPr/>
-          <a:lstStyle/>
-          <a:p>
-            <a:endParaRPr lang="en-US"/>
+          <a:bodyPr vert="horz" lIns="91440" tIns="45720" rIns="91440" bIns="45720" rtlCol="0" anchor="t">
+            <a:normAutofit/>
+          </a:bodyPr>
+          <a:lstStyle/>
+          <a:p>
+            <a:r>
+              <a:rPr lang="en-US" noProof="1"/>
+              <a:t>Auf alles (Gesamtes Projekt)</a:t>
+            </a:r>
+          </a:p>
+          <a:p>
+            <a:r>
+              <a:rPr lang="en-US" noProof="1"/>
+              <a:t>Blueprints lernen könnte</a:t>
+            </a:r>
+          </a:p>
+          <a:p>
+            <a:endParaRPr lang="en-US" noProof="1"/>
           </a:p>
         </p:txBody>
       </p:sp>
     </p:spTree>
     <p:extLst>
       <p:ext uri="{BB962C8B-B14F-4D97-AF65-F5344CB8AC3E}">
-        <p14:creationId xmlns:p14="http://schemas.microsoft.com/office/powerpoint/2010/main" val="761157137"/>
+        <p14:creationId xmlns:p14="http://schemas.microsoft.com/office/powerpoint/2010/main" val="297389937"/>
       </p:ext>
     </p:extLst>
   </p:cSld>
@@ -5239,7 +5199,7 @@
           <p:cNvPr id="2" name="Title 1">
             <a:extLst>
               <a:ext uri="{FF2B5EF4-FFF2-40B4-BE49-F238E27FC236}">
-                <a16:creationId xmlns:a16="http://schemas.microsoft.com/office/drawing/2014/main" id="{AFF46E95-2E97-E61B-88B9-6E1A97F1EF1D}"/>
+                <a16:creationId xmlns:a16="http://schemas.microsoft.com/office/drawing/2014/main" id="{1E28AFB1-8A7A-B172-D7B1-90A824228172}"/>
               </a:ext>
             </a:extLst>
           </p:cNvPr>
@@ -5257,7 +5217,23 @@
           <a:p>
             <a:r>
               <a:rPr lang="en-US"/>
-              <a:t>Reflektion</a:t>
+              <a:t>Was </a:t>
+            </a:r>
+            <a:r>
+              <a:rPr lang="en-US" err="1"/>
+              <a:t>haben</a:t>
+            </a:r>
+            <a:r>
+              <a:rPr lang="en-US"/>
+              <a:t> </a:t>
+            </a:r>
+            <a:r>
+              <a:rPr lang="en-US" err="1"/>
+              <a:t>wir</a:t>
+            </a:r>
+            <a:r>
+              <a:rPr lang="en-US"/>
+              <a:t> gelernt?</a:t>
             </a:r>
           </a:p>
         </p:txBody>
@@ -5267,7 +5243,7 @@
           <p:cNvPr id="3" name="Content Placeholder 2">
             <a:extLst>
               <a:ext uri="{FF2B5EF4-FFF2-40B4-BE49-F238E27FC236}">
-                <a16:creationId xmlns:a16="http://schemas.microsoft.com/office/drawing/2014/main" id="{617DA1C0-367D-6611-4054-E45F28C96540}"/>
+                <a16:creationId xmlns:a16="http://schemas.microsoft.com/office/drawing/2014/main" id="{A8AA9383-4EBA-9EBE-396A-538380AE735F}"/>
               </a:ext>
             </a:extLst>
           </p:cNvPr>
@@ -5280,17 +5256,47 @@
         </p:nvSpPr>
         <p:spPr/>
         <p:txBody>
-          <a:bodyPr/>
-          <a:lstStyle/>
-          <a:p>
-            <a:endParaRPr lang="en-US"/>
+          <a:bodyPr vert="horz" lIns="91440" tIns="45720" rIns="91440" bIns="45720" rtlCol="0" anchor="t">
+            <a:normAutofit/>
+          </a:bodyPr>
+          <a:lstStyle/>
+          <a:p>
+            <a:r>
+              <a:rPr lang="en-US" dirty="0"/>
+              <a:t>Wie man </a:t>
+            </a:r>
+            <a:r>
+              <a:rPr lang="en-US" dirty="0" err="1"/>
+              <a:t>mit</a:t>
+            </a:r>
+            <a:r>
+              <a:rPr lang="en-US" dirty="0"/>
+              <a:t> Unreal </a:t>
+            </a:r>
+            <a:r>
+              <a:rPr lang="en-US" dirty="0" err="1"/>
+              <a:t>umgeht</a:t>
+            </a:r>
+            <a:endParaRPr lang="en-US" dirty="0"/>
+          </a:p>
+          <a:p>
+            <a:r>
+              <a:rPr lang="en-US" dirty="0"/>
+              <a:t>Blueprint (Node Coding</a:t>
+            </a:r>
+          </a:p>
+          <a:p>
+            <a:r>
+              <a:rPr lang="en-US" dirty="0"/>
+              <a:t>Teamwork</a:t>
+            </a:r>
           </a:p>
         </p:txBody>
       </p:sp>
     </p:spTree>
     <p:extLst>
       <p:ext uri="{BB962C8B-B14F-4D97-AF65-F5344CB8AC3E}">
-        <p14:creationId xmlns:p14="http://schemas.microsoft.com/office/powerpoint/2010/main" val="4211665210"/>
+        <p14:creationId xmlns:p14="http://schemas.microsoft.com/office/powerpoint/2010/main" val="2624086703"/>
       </p:ext>
     </p:extLst>
   </p:cSld>
@@ -5616,6 +5622,23 @@
 </file>
 
 <file path=customXml/item1.xml><?xml version="1.0" encoding="utf-8"?>
+<p:properties xmlns:p="http://schemas.microsoft.com/office/2006/metadata/properties" xmlns:xsi="http://www.w3.org/2001/XMLSchema-instance" xmlns:pc="http://schemas.microsoft.com/office/infopath/2007/PartnerControls">
+  <documentManagement>
+    <_activity xmlns="7b482e70-4f35-40a3-b75e-ffa04ee0c79f" xsi:nil="true"/>
+  </documentManagement>
+</p:properties>
+</file>
+
+<file path=customXml/item2.xml><?xml version="1.0" encoding="utf-8"?>
+<?mso-contentType ?>
+<FormTemplates xmlns="http://schemas.microsoft.com/sharepoint/v3/contenttype/forms">
+  <Display>DocumentLibraryForm</Display>
+  <Edit>DocumentLibraryForm</Edit>
+  <New>DocumentLibraryForm</New>
+</FormTemplates>
+</file>
+
+<file path=customXml/item3.xml><?xml version="1.0" encoding="utf-8"?>
 <ct:contentTypeSchema xmlns:ct="http://schemas.microsoft.com/office/2006/metadata/contentType" xmlns:ma="http://schemas.microsoft.com/office/2006/metadata/properties/metaAttributes" ct:_="" ma:_="" ma:contentTypeName="Document" ma:contentTypeID="0x0101003A7443C7252A364EA82FF0EDB3C44616" ma:contentTypeVersion="16" ma:contentTypeDescription="Crée un document." ma:contentTypeScope="" ma:versionID="99dd13c5d007134322681d689c73e4af">
   <xsd:schema xmlns:xsd="http://www.w3.org/2001/XMLSchema" xmlns:xs="http://www.w3.org/2001/XMLSchema" xmlns:p="http://schemas.microsoft.com/office/2006/metadata/properties" xmlns:ns3="7b482e70-4f35-40a3-b75e-ffa04ee0c79f" xmlns:ns4="4582224d-bab5-40fa-bd6d-5f2de2104ce9" targetNamespace="http://schemas.microsoft.com/office/2006/metadata/properties" ma:root="true" ma:fieldsID="b16fc3d7505b8814540dfc36f1e50148" ns3:_="" ns4:_="">
     <xsd:import namespace="7b482e70-4f35-40a3-b75e-ffa04ee0c79f"/>
@@ -5856,24 +5879,32 @@
 </ct:contentTypeSchema>
 </file>
 
-<file path=customXml/item2.xml><?xml version="1.0" encoding="utf-8"?>
-<?mso-contentType ?>
-<FormTemplates xmlns="http://schemas.microsoft.com/sharepoint/v3/contenttype/forms">
-  <Display>DocumentLibraryForm</Display>
-  <Edit>DocumentLibraryForm</Edit>
-  <New>DocumentLibraryForm</New>
-</FormTemplates>
+<file path=customXml/itemProps1.xml><?xml version="1.0" encoding="utf-8"?>
+<ds:datastoreItem xmlns:ds="http://schemas.openxmlformats.org/officeDocument/2006/customXml" ds:itemID="{1061F33B-DBCF-4D99-8A24-A37E84CD3907}">
+  <ds:schemaRefs>
+    <ds:schemaRef ds:uri="4582224d-bab5-40fa-bd6d-5f2de2104ce9"/>
+    <ds:schemaRef ds:uri="7b482e70-4f35-40a3-b75e-ffa04ee0c79f"/>
+    <ds:schemaRef ds:uri="http://purl.org/dc/dcmitype/"/>
+    <ds:schemaRef ds:uri="http://purl.org/dc/elements/1.1/"/>
+    <ds:schemaRef ds:uri="http://purl.org/dc/terms/"/>
+    <ds:schemaRef ds:uri="http://schemas.microsoft.com/office/2006/documentManagement/types"/>
+    <ds:schemaRef ds:uri="http://schemas.microsoft.com/office/2006/metadata/properties"/>
+    <ds:schemaRef ds:uri="http://schemas.microsoft.com/office/infopath/2007/PartnerControls"/>
+    <ds:schemaRef ds:uri="http://schemas.openxmlformats.org/package/2006/metadata/core-properties"/>
+    <ds:schemaRef ds:uri="http://www.w3.org/XML/1998/namespace"/>
+  </ds:schemaRefs>
+</ds:datastoreItem>
 </file>
 
-<file path=customXml/item3.xml><?xml version="1.0" encoding="utf-8"?>
-<p:properties xmlns:p="http://schemas.microsoft.com/office/2006/metadata/properties" xmlns:xsi="http://www.w3.org/2001/XMLSchema-instance" xmlns:pc="http://schemas.microsoft.com/office/infopath/2007/PartnerControls">
-  <documentManagement>
-    <_activity xmlns="7b482e70-4f35-40a3-b75e-ffa04ee0c79f" xsi:nil="true"/>
-  </documentManagement>
-</p:properties>
+<file path=customXml/itemProps2.xml><?xml version="1.0" encoding="utf-8"?>
+<ds:datastoreItem xmlns:ds="http://schemas.openxmlformats.org/officeDocument/2006/customXml" ds:itemID="{671C1D4C-DDB7-40E3-8640-20852E4CEA3E}">
+  <ds:schemaRefs>
+    <ds:schemaRef ds:uri="http://schemas.microsoft.com/sharepoint/v3/contenttype/forms"/>
+  </ds:schemaRefs>
+</ds:datastoreItem>
 </file>
 
-<file path=customXml/itemProps1.xml><?xml version="1.0" encoding="utf-8"?>
+<file path=customXml/itemProps3.xml><?xml version="1.0" encoding="utf-8"?>
 <ds:datastoreItem xmlns:ds="http://schemas.openxmlformats.org/officeDocument/2006/customXml" ds:itemID="{8419668F-5759-4465-9DD6-CB2CD64ED883}">
   <ds:schemaRefs>
     <ds:schemaRef ds:uri="4582224d-bab5-40fa-bd6d-5f2de2104ce9"/>
@@ -5890,29 +5921,4 @@
     <ds:schemaRef ds:uri="http://www.w3.org/2001/XMLSchema"/>
   </ds:schemaRefs>
 </ds:datastoreItem>
-</file>
-
-<file path=customXml/itemProps2.xml><?xml version="1.0" encoding="utf-8"?>
-<ds:datastoreItem xmlns:ds="http://schemas.openxmlformats.org/officeDocument/2006/customXml" ds:itemID="{671C1D4C-DDB7-40E3-8640-20852E4CEA3E}">
-  <ds:schemaRefs>
-    <ds:schemaRef ds:uri="http://schemas.microsoft.com/sharepoint/v3/contenttype/forms"/>
-  </ds:schemaRefs>
-</ds:datastoreItem>
-</file>
-
-<file path=customXml/itemProps3.xml><?xml version="1.0" encoding="utf-8"?>
-<ds:datastoreItem xmlns:ds="http://schemas.openxmlformats.org/officeDocument/2006/customXml" ds:itemID="{1061F33B-DBCF-4D99-8A24-A37E84CD3907}">
-  <ds:schemaRefs>
-    <ds:schemaRef ds:uri="4582224d-bab5-40fa-bd6d-5f2de2104ce9"/>
-    <ds:schemaRef ds:uri="7b482e70-4f35-40a3-b75e-ffa04ee0c79f"/>
-    <ds:schemaRef ds:uri="http://purl.org/dc/dcmitype/"/>
-    <ds:schemaRef ds:uri="http://purl.org/dc/elements/1.1/"/>
-    <ds:schemaRef ds:uri="http://purl.org/dc/terms/"/>
-    <ds:schemaRef ds:uri="http://schemas.microsoft.com/office/2006/documentManagement/types"/>
-    <ds:schemaRef ds:uri="http://schemas.microsoft.com/office/2006/metadata/properties"/>
-    <ds:schemaRef ds:uri="http://schemas.microsoft.com/office/infopath/2007/PartnerControls"/>
-    <ds:schemaRef ds:uri="http://schemas.openxmlformats.org/package/2006/metadata/core-properties"/>
-    <ds:schemaRef ds:uri="http://www.w3.org/XML/1998/namespace"/>
-  </ds:schemaRefs>
-</ds:datastoreItem>
 </file>
</xml_diff>